<commit_message>
PC-01: exact pairwise concordance (in-fill and leave-one-country-out) in the targeting metrics; the deck's pair count reads it
Co-Authored-By: Claude Opus 5 <noreply@anthropic.com>
</commit_message>
<xml_diff>
--- a/docs/slides/MN-proxy-full-talk-2026-09.pptx
+++ b/docs/slides/MN-proxy-full-talk-2026-09.pptx
@@ -1983,7 +1983,7 @@
             </a:pPr>
             <a:r>
               <a:rPr/>
-              <a:t>DRAFT A of four candidate translations for a policy audience; keep one or two. The three readings are all computed from the same held-out predictions (in-fill, 5-fold by district, ten draws). Pairs: a Spearman correlation of 0.40 corresponds to about 63% of district pairs ordered the right way (Kendall’s tau from the correlation under a bivariate-normal approximation), against 50% for a coin toss; across borders (0.31) it is 60%. The flagged fifth: deficiency prevalence in the fifth of districts the model ranks worst averages 32.2% against 24.3% nationally (nce_targeting_summary.csv, mean over the 24 cells); a map that knew the truth would find 41.3%. Burden: the model’s worst fifth holds 22% of the deficient people, the survey’s own regional averages 20%, a perfect map 48%. The honest message is that the ranking is real but modest: it is better than the regional average a ministry would use today, and a long way from a map that knows every district, which is what the reliability ceiling explains.</a:t>
+              <a:t>DRAFT A of four candidate translations for a policy audience; keep one or two. The three readings are all computed from the same held-out predictions (in-fill, 5-fold by district, ten draws). Pairs: counted exactly from the held-out predictions (12_nce_targeting_metrics.R, PC-01: every pair of districts, ties excluded, mean over the 24 cells): the model orders 60% of district pairs the way the survey does, the survey’s own regional averages 56%, a coin toss 50%; across borders (leave-one-country-out, 22 cells) it is 55%. A Spearman of 0.40 sounds like more than it is: at district level it is six pairs in ten. The flagged fifth: deficiency prevalence in the fifth of districts the model ranks worst averages 32.2% against 24.3% nationally (nce_targeting_summary.csv, mean over the 24 cells); a map that knew the truth would find 41.3%. Burden: the model’s worst fifth holds 22% of the deficient people, the survey’s own regional averages 20%, a perfect map 48%. The honest message is that the ranking is real but modest: it is better than the regional average a ministry would use today, and a long way from a map that knows every district, which is what the reliability ceiling explains.</a:t>
             </a:r>
           </a:p>
         </p:txBody>
@@ -2229,7 +2229,7 @@
             </a:pPr>
             <a:r>
               <a:rPr/>
-              <a:t>DRAFT D. The correlation does not tell a programme whether the model is fit for a decision; this slide says which decisions, and which not. Yes: choosing which districts to visit, assess or enrol first, and where the next survey should put its clusters, because those need an order and the order is 63% right at the pair level and better than the regional average. Yes: sequencing a roll-out across districts, for the same reason. With a national anchor only: a planning prevalence per district (9.3 points median error at a 5% national sample), because the ranking has no level of its own. No: reporting a district prevalence with no survey at all, or judging whether a programme worked, because the model is cross-sectional and validated on levels at one point in time, not on change. The decision rule to offer: use it where being roughly right about the order is enough, and pair it with a survey wherever a number has to be defended.</a:t>
+              <a:t>DRAFT D. The correlation does not tell a programme whether the model is fit for a decision; this slide says which decisions, and which not. Yes: choosing which districts to visit, assess or enrol first, and where the next survey should put its clusters, because those need an order and the order is 60% right at the pair level and better than the regional average. Yes: sequencing a roll-out across districts, for the same reason. With a national anchor only: a planning prevalence per district (9.3 points median error at a 5% national sample), because the ranking has no level of its own. No: reporting a district prevalence with no survey at all, or judging whether a programme worked, because the model is cross-sectional and validated on levels at one point in time, not on change. The decision rule to offer: use it where being roughly right about the order is enough, and pair it with a survey wherever a number has to be defended.</a:t>
             </a:r>
           </a:p>
         </p:txBody>
@@ -17577,7 +17577,7 @@
                 </a:solidFill>
                 <a:latin typeface="Calibri"/>
               </a:rPr>
-              <a:t>Take any two districts: the model orders them correctly about 63% of the time</a:t>
+              <a:t>Take any two districts: the model orders them the way the survey does 60% of the time</a:t>
             </a:r>
           </a:p>
           <a:p>
@@ -17593,7 +17593,7 @@
                 </a:solidFill>
                 <a:latin typeface="Calibri"/>
               </a:rPr>
-              <a:t>A coin toss gets 50%. In a country the model has never seen, 60%.</a:t>
+              <a:t>Counted over every pair of districts. A coin toss gets 50%, the survey's own regional averages 56%; in a country the model has never seen, 55%.</a:t>
             </a:r>
           </a:p>
         </p:txBody>
@@ -18850,7 +18850,7 @@
                 </a:solidFill>
                 <a:latin typeface="Calibri"/>
               </a:rPr>
-              <a:t>Needs an order, not a number: 63% of pairs right, better than the regional average.</a:t>
+              <a:t>Needs an order, not a number: 60% of district pairs ordered as the survey does, against 56% for the regional average.</a:t>
             </a:r>
           </a:p>
         </p:txBody>

</xml_diff>

<commit_message>
Full talk on RR-12: Gambia survey-resolution conclusion; per-cell wording corrected (3 of 4 Gambia outcomes above 0.5)
Co-Authored-By: Claude Opus 5 <noreply@anthropic.com>
</commit_message>
<xml_diff>
--- a/docs/slides/MN-proxy-full-talk-2026-09.pptx
+++ b/docs/slides/MN-proxy-full-talk-2026-09.pptx
@@ -1086,7 +1086,7 @@
             </a:pPr>
             <a:r>
               <a:rPr/>
-              <a:t>On the same folds the index scores 0.29 against 0.29 for the rank-loss ensemble, 0.27 for random forest, 0.24 for the squared-error ensemble, 0.22 for the principal-component highly adaptive ridge and 0.19 for the elastic net (mean of cell medians over the 17 cells every arm scored, prevalence, in-fill; SL-01 to SL-05, rerun on the RR-10 set). Likely question: why capacity hurts. With 14 to 87 districts per country the index has no tuned parameter, and every estimator that tunes one shrinks toward the constant under squared-error cross-validation; the weighting slide quantifies this over a family of penalties.</a:t>
+              <a:t>On the same folds the index scores 0.29 against 0.28 for the rank-loss ensemble, 0.27 for random forest, 0.25 for the squared-error ensemble, 0.22 for the principal-component highly adaptive ridge and 0.19 for the elastic net (mean of cell medians over the 17 cells every arm scored, prevalence, in-fill; SL-01 to SL-05, rerun on the RR-10 set). Likely question: why capacity hurts. With 14 to 87 districts per country the index has no tuned parameter, and every estimator that tunes one shrinks toward the constant under squared-error cross-validation; the weighting slide quantifies this over a family of penalties.</a:t>
             </a:r>
           </a:p>
         </p:txBody>
@@ -1168,7 +1168,7 @@
             </a:pPr>
             <a:r>
               <a:rPr/>
-              <a:t>The January estimator, kept as the comparison arm: a SuperLearner library (mean, penalised regressions, random forest, gradient boosting, PCA-HAL, BART, geostatistical models) weighted by V-fold cross-validated performance, folds cut so that no district is split between training and validation. No penalty other than computation to add a learner: diversity, redundancy, synergy. On the same folds the index scores 0.29 against 0.29 for the rank-loss ensemble and 0.27 for random forest (17 cells, prevalence, in-fill), which is why the zero-tuning index became the headline: with 14 to 87 districts every estimator that tunes a parameter shrinks toward the constant.</a:t>
+              <a:t>The January estimator, kept as the comparison arm: a SuperLearner library (mean, penalised regressions, random forest, gradient boosting, PCA-HAL, BART, geostatistical models) weighted by V-fold cross-validated performance, folds cut so that no district is split between training and validation. No penalty other than computation to add a learner: diversity, redundancy, synergy. On the same folds the index scores 0.29 against 0.28 for the rank-loss ensemble and 0.27 for random forest (17 cells, prevalence, in-fill), which is why the zero-tuning index became the headline: with 14 to 87 districts every estimator that tunes a parameter shrinks toward the constant.</a:t>
             </a:r>
           </a:p>
         </p:txBody>
@@ -1988,7 +1988,7 @@
             </a:pPr>
             <a:r>
               <a:rPr/>
-              <a:t>The averages elsewhere in this deck hide a spread that matters: 6 of the 18 in-country cells reach a held-out Spearman of 0.5 or more on the biomarker level (mean 0.64, bold on the axis), the rest average 0.28. Rows are the country-outcome cells sorted by the index’s in-fill ranking; the filled point is the deployed model with its interval over the ten fold draws, the cross is the survey’s own regional average (the number a ministry would use), the hollow circle is the best of the other arms (spatial smoother, smoother plus covariates, elastic nets) picked on the same held-out score, so it is optimistic and shown only to say how much a different estimator could have added: little. The middle and right panels are the region and country estimands for the same cells. The weak cells are of two kinds: outcomes too rare to measure at district level (Malawi’s vitamin A cells at under 1% national prevalence: 2 cells, mean 0.26) and zinc (Malawi only, mean -0.07), where the survey’s own district estimates carry almost no signal to recover; The Gambia, with 30 large districts and several clusters in each, is strong on all four of its outcomes; the next slides show the same cells on the prevalence and concentration scales, and the scatter after them puts the weak cells against their prevalence. Sierra Leone’s 14 districts are not scored in-fill.</a:t>
+              <a:t>The averages elsewhere in this deck hide a spread that matters: 6 of the 18 in-country cells reach a held-out Spearman of 0.5 or more on the biomarker level (mean 0.64, bold on the axis), the rest average 0.28. Rows are the country-outcome cells sorted by the index’s in-fill ranking; the filled point is the deployed model with its interval over the ten fold draws, the cross is the survey’s own regional average (the number a ministry would use), the hollow circle is the best of the other arms (spatial smoother, smoother plus covariates, elastic nets) picked on the same held-out score, so it is optimistic and shown only to say how much a different estimator could have added: little. The middle and right panels are the region and country estimands for the same cells. The weak cells are of two kinds: outcomes too rare to measure at district level (Malawi’s vitamin A cells at under 1% national prevalence: 2 cells, mean 0.26) and zinc (Malawi only, mean -0.07), where the survey’s own district estimates carry almost no signal to recover; The Gambia, with 30 large districts and several clusters in each, clears the line on 3 of its 4 outcomes and scores 0.41 on the fourth (child iron), above the other countries’ average; the next slides show the same cells on the prevalence and concentration scales, and the scatter after them puts the weak cells against their prevalence. Sierra Leone’s 14 districts are not scored in-fill.</a:t>
             </a:r>
           </a:p>
         </p:txBody>
@@ -2234,7 +2234,7 @@
             </a:pPr>
             <a:r>
               <a:rPr/>
-              <a:t>Each point is a country-outcome cell: the index’s in-fill ranking accuracy against how common the deficiency is nationally. Rarity hurts at the extreme: below 1% prevalence (Malawi’s two vitamin A cells, mean 0.26) the survey finds a handful of deficient respondents per district and its district estimates are mostly zero, so no predictor can recover an order; at 2 to 4% (The Gambia’s and Ghana’s women’s vitamin A) the ranking still works. Above that, the spread is about the survey more than the nutrient: The Gambia’s 30 districts with several clusters each are strong on every outcome, Ghana’s and Malawi’s single-cluster districts are mixed. Zinc (Malawi only, -0.07) is the other failure and is not a rarity problem: serum zinc is unadjusted, drawn under fasting rules that vary by cluster, and the survey’s own district means are close to noise. Everything the deck claims about ranking rests on the cells above the dotted line: 6 of 18, iron, vitamin A where it is common, folate and B12, in three countries. Likely question: why not just report those. Because the cut is chosen on the same held-out scores, so the strong-cell mean of 0.64 is a description, not a promise; the promise for a new country is the transport slide’s pre-registered climate-and-soil index.</a:t>
+              <a:t>Each point is a country-outcome cell: the index’s in-fill ranking accuracy against how common the deficiency is nationally. Rarity hurts at the extreme: below 1% prevalence (Malawi’s two vitamin A cells, mean 0.26) the survey finds a handful of deficient respondents per district and its district estimates are mostly zero, so no predictor can recover an order; at 2 to 4% (The Gambia’s and Ghana’s women’s vitamin A) the ranking still works. Above that, the spread is about the survey more than the nutrient: The Gambia’s 30 districts with several clusters each score 0.41 to 0.70 (3 of 4 above the line), Ghana’s and Malawi’s single-cluster districts are mixed (3 of 14). Zinc (Malawi only, -0.07) is the other failure and is not a rarity problem: serum zinc is unadjusted, drawn under fasting rules that vary by cluster, and the survey’s own district means are close to noise. Everything the deck claims about ranking rests on the cells above the dotted line: 6 of 18, iron, vitamin A where it is common, folate and B12, in three countries. Likely question: why not just report those. Because the cut is chosen on the same held-out scores, so the strong-cell mean of 0.64 is a description, not a promise; the promise for a new country is the transport slide’s pre-registered climate-and-soil index.</a:t>
             </a:r>
           </a:p>
         </p:txBody>
@@ -2890,7 +2890,7 @@
             </a:pPr>
             <a:r>
               <a:rPr/>
-              <a:t>The index is linear in the rank-normalised predictors, so its component weights project back exactly onto the 575 columns (scripts 57 and 58). Shown: the ten largest weights in the pooled four-country fit on the biomarker level, coloured by data source; a star marks a sign not reproduced in every country’s own fit. No predictor carries more than 2% of the index’s variance; the satellite embedding, climate and soil together carry 40% to 54% depending on the outcome. Likely question: whether these are causes. They are not; the weights say where deficiency is. Livestock density carrying a positive sign for iron and B12 is ecological: pastoral zones are the dry, poor zones in these countries.</a:t>
+              <a:t>The index is linear in the rank-normalised predictors, so its component weights project back exactly onto the 575 columns (scripts 57 and 58). Shown: the ten largest weights in the pooled four-country fit on the biomarker level, coloured by data source; a star marks a sign not reproduced in every country’s own fit. No predictor carries more than 2% of the index’s variance; the satellite embedding, climate and soil together carry 39% to 54% depending on the outcome. Likely question: whether these are causes. They are not; the weights say where deficiency is. Livestock density carrying a positive sign for iron and B12 is ecological: pastoral zones are the dry, poor zones in these countries.</a:t>
             </a:r>
           </a:p>
         </p:txBody>
@@ -3218,7 +3218,7 @@
             </a:pPr>
             <a:r>
               <a:rPr/>
-              <a:t>Source: results/tables/protocol_v2/index_importance_columns.csv, scope “loco”: the index fitted on three countries, projected back to columns, for each of the 22 held-out country and outcome combinations on the biomarker level; a column counts once per fit in which it is among the twenty largest standardised weights. Every column named on the slide keeps the same sign in every fit where it appears (33 of the 39 columns that recur in five or more fits are unanimous). The pattern is the one on the previous two slides seen from the other side: what a model trained elsewhere reaches for in a new country is the physical environment and the modelled nutrition surfaces built from it, not the country’s own survey items. The staple-price and malaria signs are worth saying aloud: relatively expensive staples mark market-integrated, better-off districts, and high malaria transmission marks the wet, productive lowlands where diets are more diverse; neither is a mechanism to act on.</a:t>
+              <a:t>Source: results/tables/protocol_v2/index_importance_columns.csv, scope “loco”: the index fitted on three countries, projected back to columns, for each of the 22 held-out country and outcome combinations on the biomarker level; a column counts once per fit in which it is among the twenty largest standardised weights. Every column named on the slide keeps the same sign in every fit where it appears (34 of the 41 columns that recur in five or more fits are unanimous). The pattern is the one on the previous two slides seen from the other side: what a model trained elsewhere reaches for in a new country is the physical environment and the modelled nutrition surfaces built from it, not the country’s own survey items. The staple-price and malaria signs are worth saying aloud: relatively expensive staples mark market-integrated, better-off districts, and high malaria transmission marks the wet, productive lowlands where diets are more diverse; neither is a mechanism to act on.</a:t>
             </a:r>
           </a:p>
         </p:txBody>
@@ -3956,7 +3956,7 @@
             </a:pPr>
             <a:r>
               <a:rPr/>
-              <a:t>Concept slide: content in MN-proxy-full-talk-2026-09.concept.yaml.</a:t>
+              <a:t>Five conclusions, each with its number on the slide. The fifth is the one the per-cell slides added: the model’s accuracy tracks the survey’s district resolution more than the nutrient. The Gambia, whose 30 districts each hold several clusters, ranks 0.41 to 0.70 across its 4 outcomes, 3 of them at or above 0.5 and the fourth (child iron) still above the other countries’ average; Ghana and Malawi, with one cluster in most districts, average 0.34 with 3 of 14 cells above the line. So the ceiling slide and this one say the same thing from two sides: give the survey enough clusters per district and the proxies can recover its order; starve it and nothing can. Results in this deck are from the RR-12 re-run on the 575-column set (16 September 2026).</a:t>
             </a:r>
           </a:p>
         </p:txBody>
@@ -4776,7 +4776,7 @@
             </a:pPr>
             <a:r>
               <a:rPr/>
-              <a:t>The production weights are the infinite-penalty limit of a ridge regression on the components, so the rows are points along that family plus other sources of evidence for the weights (soft thresholding, meta-analytic replication across training countries, decorrelation across domains). Same folds and cells as every other arm; five in-fill draws. The one-SE rules return the null model in some cells (18 of 22 transport cells scored for the elastic net). The twenty-predictor composite gains -0.053 across borders (better in 8 of 22) and costs -0.03 in-fill. The soft threshold gained 0.02 across borders on the direct DHS estimates and -0.004 on the smoothed ones, so that gain was a property of noisy inputs. Both gains were found among 21 arms on these cells and are pre-registered for the next country rather than adopted. Prevalence-target version in the appendix.</a:t>
+              <a:t>The production weights are the infinite-penalty limit of a ridge regression on the components, so the rows are points along that family plus other sources of evidence for the weights (soft thresholding, meta-analytic replication across training countries, decorrelation across domains). Same folds and cells as every other arm; five in-fill draws. The one-SE rules return the null model in some cells (18 of 22 transport cells scored for the elastic net). The twenty-predictor composite gains -0.069 across borders (better in 6 of 22) and costs -0.04 in-fill. The soft threshold gained 0.02 across borders on the direct DHS estimates and -0.002 on the smoothed ones, so that gain was a property of noisy inputs. Both gains were found among 21 arms on these cells and are pre-registered for the next country rather than adopted. Prevalence-target version in the appendix.</a:t>
             </a:r>
           </a:p>
         </p:txBody>
@@ -15109,7 +15109,7 @@
                 </a:solidFill>
                 <a:latin typeface="Calibri"/>
               </a:rPr>
-              <a:t>Same folds: index 0.29 against 0.29 for the rank-loss ensemble and 0.27 for random forest.</a:t>
+              <a:t>Same folds: index 0.29 against 0.28 for the rank-loss ensemble and 0.27 for random forest.</a:t>
             </a:r>
           </a:p>
         </p:txBody>
@@ -25429,7 +25429,7 @@
         <p:spPr>
           <a:xfrm>
             <a:off x="932688" y="1783080"/>
-            <a:ext cx="822960" cy="731520"/>
+            <a:ext cx="576072" cy="512064"/>
           </a:xfrm>
           <a:prstGeom prst="rect">
             <a:avLst/>
@@ -25445,7 +25445,7 @@
         <p:spPr>
           <a:xfrm>
             <a:off x="1984248" y="1691640"/>
-            <a:ext cx="9326880" cy="914400"/>
+            <a:ext cx="9326880" cy="694944"/>
           </a:xfrm>
           <a:prstGeom prst="rect">
             <a:avLst/>
@@ -25460,7 +25460,7 @@
           <a:p>
             <a:pPr algn="l"/>
             <a:r>
-              <a:rPr sz="2000" b="1">
+              <a:rPr sz="1700" b="1">
                 <a:solidFill>
                   <a:srgbClr val="1F4E79"/>
                 </a:solidFill>
@@ -25476,7 +25476,7 @@
               </a:spcBef>
             </a:pPr>
             <a:r>
-              <a:rPr sz="1400" b="0">
+              <a:rPr sz="1250" b="0">
                 <a:solidFill>
                   <a:srgbClr val="333333"/>
                 </a:solidFill>
@@ -25503,8 +25503,8 @@
         </p:blipFill>
         <p:spPr>
           <a:xfrm>
-            <a:off x="932688" y="2880360"/>
-            <a:ext cx="731520" cy="731520"/>
+            <a:off x="932688" y="2660904"/>
+            <a:ext cx="512064" cy="512064"/>
           </a:xfrm>
           <a:prstGeom prst="rect">
             <a:avLst/>
@@ -25519,8 +25519,8 @@
         </p:nvSpPr>
         <p:spPr>
           <a:xfrm>
-            <a:off x="1984248" y="2788920"/>
-            <a:ext cx="9326880" cy="914400"/>
+            <a:off x="1984248" y="2569464"/>
+            <a:ext cx="9326880" cy="694944"/>
           </a:xfrm>
           <a:prstGeom prst="rect">
             <a:avLst/>
@@ -25535,7 +25535,7 @@
           <a:p>
             <a:pPr algn="l"/>
             <a:r>
-              <a:rPr sz="2000" b="1">
+              <a:rPr sz="1700" b="1">
                 <a:solidFill>
                   <a:srgbClr val="1F4E79"/>
                 </a:solidFill>
@@ -25551,7 +25551,7 @@
               </a:spcBef>
             </a:pPr>
             <a:r>
-              <a:rPr sz="1400" b="0">
+              <a:rPr sz="1250" b="0">
                 <a:solidFill>
                   <a:srgbClr val="333333"/>
                 </a:solidFill>
@@ -25578,8 +25578,8 @@
         </p:blipFill>
         <p:spPr>
           <a:xfrm>
-            <a:off x="932688" y="3977640"/>
-            <a:ext cx="731520" cy="731520"/>
+            <a:off x="932688" y="3538728"/>
+            <a:ext cx="512064" cy="512064"/>
           </a:xfrm>
           <a:prstGeom prst="rect">
             <a:avLst/>
@@ -25594,8 +25594,8 @@
         </p:nvSpPr>
         <p:spPr>
           <a:xfrm>
-            <a:off x="1984248" y="3886200"/>
-            <a:ext cx="9326880" cy="914400"/>
+            <a:off x="1984248" y="3447288"/>
+            <a:ext cx="9326880" cy="694944"/>
           </a:xfrm>
           <a:prstGeom prst="rect">
             <a:avLst/>
@@ -25610,7 +25610,7 @@
           <a:p>
             <a:pPr algn="l"/>
             <a:r>
-              <a:rPr sz="2000" b="1">
+              <a:rPr sz="1700" b="1">
                 <a:solidFill>
                   <a:srgbClr val="1F4E79"/>
                 </a:solidFill>
@@ -25626,7 +25626,7 @@
               </a:spcBef>
             </a:pPr>
             <a:r>
-              <a:rPr sz="1400" b="0">
+              <a:rPr sz="1250" b="0">
                 <a:solidFill>
                   <a:srgbClr val="333333"/>
                 </a:solidFill>
@@ -25653,8 +25653,8 @@
         </p:blipFill>
         <p:spPr>
           <a:xfrm>
-            <a:off x="932688" y="5074920"/>
-            <a:ext cx="822960" cy="731520"/>
+            <a:off x="932688" y="4416552"/>
+            <a:ext cx="576072" cy="512064"/>
           </a:xfrm>
           <a:prstGeom prst="rect">
             <a:avLst/>
@@ -25669,8 +25669,8 @@
         </p:nvSpPr>
         <p:spPr>
           <a:xfrm>
-            <a:off x="1984248" y="4983480"/>
-            <a:ext cx="9326880" cy="914400"/>
+            <a:off x="1984248" y="4325112"/>
+            <a:ext cx="9326880" cy="694944"/>
           </a:xfrm>
           <a:prstGeom prst="rect">
             <a:avLst/>
@@ -25685,7 +25685,7 @@
           <a:p>
             <a:pPr algn="l"/>
             <a:r>
-              <a:rPr sz="2000" b="1">
+              <a:rPr sz="1700" b="1">
                 <a:solidFill>
                   <a:srgbClr val="1F4E79"/>
                 </a:solidFill>
@@ -25701,13 +25701,88 @@
               </a:spcBef>
             </a:pPr>
             <a:r>
-              <a:rPr sz="1400" b="0">
+              <a:rPr sz="1250" b="0">
                 <a:solidFill>
                   <a:srgbClr val="333333"/>
                 </a:solidFill>
                 <a:latin typeface="Calibri"/>
               </a:rPr>
               <a:t>District error 9.3 points at 5% of a full sample, matched by a district survey at 25%.</a:t>
+            </a:r>
+          </a:p>
+        </p:txBody>
+      </p:sp>
+      <p:pic>
+        <p:nvPicPr>
+          <p:cNvPr id="11" name="Picture 10" descr="layer-group_blue.png"/>
+          <p:cNvPicPr>
+            <a:picLocks noChangeAspect="1"/>
+          </p:cNvPicPr>
+          <p:nvPr/>
+        </p:nvPicPr>
+        <p:blipFill>
+          <a:blip r:embed="rId7"/>
+          <a:stretch>
+            <a:fillRect/>
+          </a:stretch>
+        </p:blipFill>
+        <p:spPr>
+          <a:xfrm>
+            <a:off x="932688" y="5294376"/>
+            <a:ext cx="576072" cy="512064"/>
+          </a:xfrm>
+          <a:prstGeom prst="rect">
+            <a:avLst/>
+          </a:prstGeom>
+        </p:spPr>
+      </p:pic>
+      <p:sp>
+        <p:nvSpPr>
+          <p:cNvPr id="12" name="TextBox 11"/>
+          <p:cNvSpPr txBox="1"/>
+          <p:nvPr/>
+        </p:nvSpPr>
+        <p:spPr>
+          <a:xfrm>
+            <a:off x="1984248" y="5202936"/>
+            <a:ext cx="9326880" cy="694944"/>
+          </a:xfrm>
+          <a:prstGeom prst="rect">
+            <a:avLst/>
+          </a:prstGeom>
+          <a:noFill/>
+        </p:spPr>
+        <p:txBody>
+          <a:bodyPr wrap="square" anchor="ctr" lIns="45720" rIns="45720" tIns="27432" bIns="27432">
+            <a:spAutoFit/>
+          </a:bodyPr>
+          <a:lstStyle/>
+          <a:p>
+            <a:pPr algn="l"/>
+            <a:r>
+              <a:rPr sz="1700" b="1">
+                <a:solidFill>
+                  <a:srgbClr val="1F4E79"/>
+                </a:solidFill>
+                <a:latin typeface="Calibri"/>
+              </a:rPr>
+              <a:t>Where the survey resolves districts, so does the model: The Gambia 0.41 to 0.70</a:t>
+            </a:r>
+          </a:p>
+          <a:p>
+            <a:pPr algn="l">
+              <a:spcBef>
+                <a:spcPts val="300"/>
+              </a:spcBef>
+            </a:pPr>
+            <a:r>
+              <a:rPr sz="1250" b="0">
+                <a:solidFill>
+                  <a:srgbClr val="333333"/>
+                </a:solidFill>
+                <a:latin typeface="Calibri"/>
+              </a:rPr>
+              <a:t>Several clusters per district; 3 of 4 outcomes above 0.5. Ghana's and Malawi's single-cluster districts average 0.34 (3 of 14).</a:t>
             </a:r>
           </a:p>
         </p:txBody>
@@ -34888,7 +34963,7 @@
                       </a:pPr>
                       <a:r>
                         <a:rPr sz="1000"/>
-                        <a:t>10.0</a:t>
+                        <a:t>10.2</a:t>
                       </a:r>
                     </a:p>
                   </a:txBody>
@@ -34905,22 +34980,22 @@
                       </a:pPr>
                       <a:r>
                         <a:rPr sz="1000"/>
-                        <a:t>npp_npp_t0</a:t>
-                      </a:r>
-                    </a:p>
-                  </a:txBody>
-                </a:tc>
-                <a:tc>
-                  <a:txBody>
-                    <a:bodyPr/>
-                    <a:lstStyle/>
-                    <a:p>
-                      <a:pPr lvl="0" indent="0" marL="0" algn="l">
-                        <a:buNone/>
-                      </a:pPr>
-                      <a:r>
-                        <a:rPr sz="1000"/>
-                        <a:t>Ecosystem productivity/greenness</a:t>
+                        <a:t>ihme_overweightprevalence</a:t>
+                      </a:r>
+                    </a:p>
+                  </a:txBody>
+                </a:tc>
+                <a:tc>
+                  <a:txBody>
+                    <a:bodyPr/>
+                    <a:lstStyle/>
+                    <a:p>
+                      <a:pPr lvl="0" indent="0" marL="0" algn="l">
+                        <a:buNone/>
+                      </a:pPr>
+                      <a:r>
+                        <a:rPr sz="1000"/>
+                        <a:t>Child anthropometry</a:t>
                       </a:r>
                     </a:p>
                   </a:txBody>
@@ -34935,22 +35010,22 @@
                       </a:pPr>
                       <a:r>
                         <a:rPr sz="1000"/>
-                        <a:t>5</a:t>
-                      </a:r>
-                    </a:p>
-                  </a:txBody>
-                </a:tc>
-                <a:tc>
-                  <a:txBody>
-                    <a:bodyPr/>
-                    <a:lstStyle/>
-                    <a:p>
-                      <a:pPr lvl="0" indent="0" marL="0" algn="l">
-                        <a:buNone/>
-                      </a:pPr>
-                      <a:r>
-                        <a:rPr sz="1000"/>
-                        <a:t>—–</a:t>
+                        <a:t>4</a:t>
+                      </a:r>
+                    </a:p>
+                  </a:txBody>
+                </a:tc>
+                <a:tc>
+                  <a:txBody>
+                    <a:bodyPr/>
+                    <a:lstStyle/>
+                    <a:p>
+                      <a:pPr lvl="0" indent="0" marL="0" algn="l">
+                        <a:buNone/>
+                      </a:pPr>
+                      <a:r>
+                        <a:rPr sz="1000"/>
+                        <a:t>—-</a:t>
                       </a:r>
                     </a:p>
                   </a:txBody>
@@ -34965,7 +35040,7 @@
                       </a:pPr>
                       <a:r>
                         <a:rPr sz="1000"/>
-                        <a:t>15.8</a:t>
+                        <a:t>6.0</a:t>
                       </a:r>
                     </a:p>
                   </a:txBody>
@@ -34982,22 +35057,22 @@
                       </a:pPr>
                       <a:r>
                         <a:rPr sz="1000"/>
-                        <a:t>ihme_overweightprevalence</a:t>
-                      </a:r>
-                    </a:p>
-                  </a:txBody>
-                </a:tc>
-                <a:tc>
-                  <a:txBody>
-                    <a:bodyPr/>
-                    <a:lstStyle/>
-                    <a:p>
-                      <a:pPr lvl="0" indent="0" marL="0" algn="l">
-                        <a:buNone/>
-                      </a:pPr>
-                      <a:r>
-                        <a:rPr sz="1000"/>
-                        <a:t>Child anthropometry</a:t>
+                        <a:t>map_sy_pf_mortality_rate</a:t>
+                      </a:r>
+                    </a:p>
+                  </a:txBody>
+                </a:tc>
+                <a:tc>
+                  <a:txBody>
+                    <a:bodyPr/>
+                    <a:lstStyle/>
+                    <a:p>
+                      <a:pPr lvl="0" indent="0" marL="0" algn="l">
+                        <a:buNone/>
+                      </a:pPr>
+                      <a:r>
+                        <a:rPr sz="1000"/>
+                        <a:t>Infection and inflammation burden</a:t>
                       </a:r>
                     </a:p>
                   </a:txBody>
@@ -35042,7 +35117,7 @@
                       </a:pPr>
                       <a:r>
                         <a:rPr sz="1000"/>
-                        <a:t>6.0</a:t>
+                        <a:t>8.0</a:t>
                       </a:r>
                     </a:p>
                   </a:txBody>
@@ -35059,22 +35134,22 @@
                       </a:pPr>
                       <a:r>
                         <a:rPr sz="1000"/>
-                        <a:t>map_sy_pf_mortality_rate</a:t>
-                      </a:r>
-                    </a:p>
-                  </a:txBody>
-                </a:tc>
-                <a:tc>
-                  <a:txBody>
-                    <a:bodyPr/>
-                    <a:lstStyle/>
-                    <a:p>
-                      <a:pPr lvl="0" indent="0" marL="0" algn="l">
-                        <a:buNone/>
-                      </a:pPr>
-                      <a:r>
-                        <a:rPr sz="1000"/>
-                        <a:t>Infection and inflammation burden</a:t>
+                        <a:t>npp_gpp_t0</a:t>
+                      </a:r>
+                    </a:p>
+                  </a:txBody>
+                </a:tc>
+                <a:tc>
+                  <a:txBody>
+                    <a:bodyPr/>
+                    <a:lstStyle/>
+                    <a:p>
+                      <a:pPr lvl="0" indent="0" marL="0" algn="l">
+                        <a:buNone/>
+                      </a:pPr>
+                      <a:r>
+                        <a:rPr sz="1000"/>
+                        <a:t>Ecosystem productivity/greenness</a:t>
                       </a:r>
                     </a:p>
                   </a:txBody>
@@ -35119,7 +35194,7 @@
                       </a:pPr>
                       <a:r>
                         <a:rPr sz="1000"/>
-                        <a:t>7.8</a:t>
+                        <a:t>14.2</a:t>
                       </a:r>
                     </a:p>
                   </a:txBody>
@@ -35136,7 +35211,7 @@
                       </a:pPr>
                       <a:r>
                         <a:rPr sz="1000"/>
-                        <a:t>npp_gpp_t0</a:t>
+                        <a:t>npp_npp_t0</a:t>
                       </a:r>
                     </a:p>
                   </a:txBody>
@@ -35196,7 +35271,7 @@
                       </a:pPr>
                       <a:r>
                         <a:rPr sz="1000"/>
-                        <a:t>14.0</a:t>
+                        <a:t>14.8</a:t>
                       </a:r>
                     </a:p>
                   </a:txBody>
@@ -35504,7 +35579,7 @@
                       </a:pPr>
                       <a:r>
                         <a:rPr sz="1000"/>
-                        <a:t>7.0</a:t>
+                        <a:t>7.3</a:t>
                       </a:r>
                     </a:p>
                   </a:txBody>
@@ -35735,7 +35810,7 @@
                       </a:pPr>
                       <a:r>
                         <a:rPr sz="1000"/>
-                        <a:t>8.3</a:t>
+                        <a:t>8.7</a:t>
                       </a:r>
                     </a:p>
                   </a:txBody>
@@ -35812,7 +35887,7 @@
             </a:pPr>
             <a:r>
               <a:rPr sz="1800"/>
-              <a:t>Alternative weightings of the same components on the biomarker level. In-country every joint fit loses to the marginal-correlation weights (ridge -0.04, elastic net -0.07, lasso -0.07). Across borders the decorrelated index gains +0.002 (better in 12 of 22).</a:t>
+              <a:t>Alternative weightings of the same components on the biomarker level. In-country every joint fit loses to the marginal-correlation weights (ridge -0.04, elastic net -0.07, lasso -0.06). Across borders the decorrelated index gains +0.005 (better in 12 of 22).</a:t>
             </a:r>
           </a:p>
         </p:txBody>
@@ -35914,7 +35989,7 @@
             </a:pPr>
             <a:r>
               <a:rPr sz="1800"/>
-              <a:t>Equal-weight composites of the top 5, 10 and 20 predictors, membership chosen inside each training fold by back-projected index weight. Twenty predictors cost -0.03 in-fill and gain -0.053 across borders; five predictors cost -0.06 in-fill.</a:t>
+              <a:t>Equal-weight composites of the top 5, 10 and 20 predictors, membership chosen inside each training fold by back-projected index weight. Twenty predictors cost -0.04 in-fill and gain -0.069 across borders; five predictors cost -0.06 in-fill.</a:t>
             </a:r>
           </a:p>
         </p:txBody>
@@ -38511,7 +38586,7 @@
             </a:pPr>
             <a:r>
               <a:rPr sz="1800"/>
-              <a:t>Person-level SuperLearner under district-blocked folds, Brier skill over the national prevalence, by country and outcome. Mean AUC over 18 cells: 0.52 for survey variables, 0.51 for district proxies, 0.53 for both.</a:t>
+              <a:t>Person-level SuperLearner under district-blocked folds, Brier skill over the national prevalence, by country and outcome. Mean AUC over 18 cells: 0.52 for survey variables, 0.50 for district proxies, 0.53 for both.</a:t>
             </a:r>
           </a:p>
         </p:txBody>

</xml_diff>